<commit_message>
Fix QR redirect (service key + rawPath fallback); revert onSignedIn guard
</commit_message>
<xml_diff>
--- a/ptorro-digital/sales/ptorro-digital-pitch.pptx
+++ b/ptorro-digital/sales/ptorro-digital-pitch.pptx
@@ -7033,7 +7033,7 @@
                 <a:ea typeface="Calibri" pitchFamily="34" charset="-122"/>
                 <a:cs typeface="Calibri" pitchFamily="34" charset="-120"/>
               </a:rPr>
-              <a:t>No Contract. No Lock-In.</a:t>
+              <a:t>You Own It. Full Rights.</a:t>
             </a:r>
             <a:endParaRPr lang="en-US" sz="1250" dirty="0"/>
           </a:p>
@@ -7072,7 +7072,7 @@
                 <a:ea typeface="Calibri" pitchFamily="34" charset="-122"/>
                 <a:cs typeface="Calibri" pitchFamily="34" charset="-120"/>
               </a:rPr>
-              <a:t>Your site is yours. Forever.</a:t>
+              <a:t>Your content, your design — always.</a:t>
             </a:r>
             <a:endParaRPr lang="en-US" sz="1050" dirty="0"/>
           </a:p>

</xml_diff>